<commit_message>
dwdsurf option deck rebuilt on jwst_ote_designc (Dave: use Luis's deck, exercise every option incl. orient xy); PLAN/reply note the runner 'elts' fix
Seg2 (element 5) poked alone through run_sensitivities (model 512, grid 63,
stop 25, centre field): under the mean reference the 17 other segments
carry one constant, 5.4% (Kr) / 4.5% (Kc) of the poked rms, equal to
6e-16; under chief exactly 0; PTT removal converts the offset into a
7.0e-4 rms tilt across the whole pupil and erases the reference
difference; the raw array is the xy map transposed; sign negates.
Orientation anchor: Seg2 at (X,Y) = (-1137,+657) mm lands at (+10,-6.5)
px -- columns along xGrid = -X, rows along yGrid = -Y.  Stacked multi
Jacobians are reconstructed with macos.v2m on indxall (tiled field
canvas) and the centre tile read from field_table.  Style gate clean;
DRAFT, no export mark.  Resources 30b6627 carries the runner 'elts' fix.

Co-Authored-By: Claude Fable 5.1 <noreply@anthropic.com>
</commit_message>
<xml_diff>
--- a/demo_session/deck_dwdsurf_options.pptx
+++ b/demo_session/deck_dwdsurf_options.pptx
@@ -3126,7 +3126,7 @@
                 </a:solidFill>
                 <a:latin typeface="Arial"/>
               </a:rPr>
-              <a:t>dw/dsurf on a segmented pupil: what each option does to one segment's column</a:t>
+              <a:t>dw/dsurf on the JWST OTE deck: what each option does to one segment's column</a:t>
             </a:r>
           </a:p>
           <a:p>
@@ -3142,7 +3142,7 @@
                 </a:solidFill>
                 <a:latin typeface="Arial"/>
               </a:rPr>
-              <a:t>e5hex1, 7 hex segments, model 128, 63-ray grid; segment 2 (element 3) poked alone in radius (Kr) and conic (Kc)</a:t>
+              <a:t>jwst_ote_designc.in (Luis's zoom deck), model 512, 63-ray grid, stop at the FSM (element 25), wavefront read at the ExitPupil Return (27); Seg2 (element 5) poked alone in radius (Kr) and conic (Kc) through run_sensitivities, centre field</a:t>
             </a:r>
           </a:p>
         </p:txBody>
@@ -3181,7 +3181,7 @@
                 </a:solidFill>
                 <a:latin typeface="Arial"/>
               </a:rPr>
-              <a:t>DRAFT 2026-09-09.  Driver macos.dw_dsurf; every option is also a run_sensitivities option since this date.</a:t>
+              <a:t>DRAFT 2026-09-09.  Every option shown is a run_sensitivities option since this date ('orient', 'sign', 'opd_ref', and 'elts' now reach the dwdsurf channel).  Numbers: dW/dp per unit parameter, mm of OPD per mm (Kr) / per unit (Kc), centre field, single configuration.</a:t>
             </a:r>
           </a:p>
         </p:txBody>
@@ -3254,7 +3254,7 @@
                 </a:solidFill>
                 <a:latin typeface="Arial"/>
               </a:rPr>
-              <a:t>mean reference: one constant on the other six; chief reference: exactly zero</a:t>
+              <a:t>mean reference: one constant on the other 17; chief reference: exactly zero</a:t>
             </a:r>
           </a:p>
         </p:txBody>
@@ -3305,7 +3305,7 @@
       </p:sp>
       <p:pic>
         <p:nvPicPr>
-          <p:cNvPr id="4" name="Picture 3" descr="dwdsurf_ref.png"/>
+          <p:cNvPr id="4" name="Picture 3" descr="dwdsurf_jwst_ref.png"/>
           <p:cNvPicPr>
             <a:picLocks noChangeAspect="1"/>
           </p:cNvPicPr>
@@ -3319,8 +3319,8 @@
         </p:blipFill>
         <p:spPr>
           <a:xfrm>
-            <a:off x="2634483" y="1298448"/>
-            <a:ext cx="6922727" cy="4177792"/>
+            <a:off x="2720448" y="1298448"/>
+            <a:ext cx="6750798" cy="4177792"/>
           </a:xfrm>
           <a:prstGeom prst="rect">
             <a:avLst/>
@@ -3361,7 +3361,7 @@
                 </a:solidFill>
                 <a:latin typeface="Arial"/>
               </a:rPr>
-              <a:t>Kr and Kc columns of segment 2 under opd_ref = mean (left) and chief (right): the six unpoked segments carry a flat offset on the left and exactly nothing on the right; the colour scale is +-3x that offset, so the poked segment saturates.</a:t>
+              <a:t>Kr and Kc columns of Seg2 under opd_ref = mean (left) and chief (right): the 17 unpoked segments carry a flat offset on the left and exactly nothing on the right; the colour scale is +-3x that offset, so the poked segment saturates.</a:t>
             </a:r>
           </a:p>
         </p:txBody>
@@ -3400,7 +3400,7 @@
                 </a:solidFill>
                 <a:latin typeface="Arial"/>
               </a:rPr>
-              <a:t>Offset on the unpoked segments under mean = -(N_k/N) x mean(poked response): Kr 4.32e-4, Kc 2.04e-2 per unit parameter (13% / 11% of the poked segment's rms), equal on all six to 3e-16.  OPD in mm per mm of Kr / per unit Kc; orient xy, sign opl, remove_ptt off.</a:t>
+              <a:t>Offset on the unpoked segments under mean = -(N_k/N) x mean(poked response): Kr 4.40e-4, Kc 1.66e-2 per unit parameter (5.4% / 4.5% of the poked segment's rms), equal on all 17 to 6e-16; the mean and chief columns differ by that one constant everywhere (1.4e-12 relative).  orient xy, sign opl, surf_remove_ptt off.</a:t>
             </a:r>
           </a:p>
         </p:txBody>
@@ -3836,7 +3836,7 @@
                 </a:solidFill>
                 <a:latin typeface="Arial"/>
               </a:rPr>
-              <a:t>the reference is one ray on the centre segment; any other segment's poke leaves it alone -&gt; other segments read 0</a:t>
+              <a:t>the reference is one ray; on this deck it passes through the virtual centre segment (element 4), so every REAL segment's poke leaves it alone and the other segments read 0</a:t>
             </a:r>
           </a:p>
         </p:txBody>
@@ -3957,7 +3957,7 @@
                 </a:solidFill>
                 <a:latin typeface="Arial"/>
               </a:rPr>
-              <a:t>poking the centre segment moves the chief's path too; the others then read -m(chief), 5% of that segment's rms for Kr.  A fixed nominal reference length (engine OPDRefRayLen branch, one api wrapper) localises every column</a:t>
+              <a:t>a deck whose chief ray sits on a real segment (e5hex1: the centre one) moves the reference when that segment is poked; the others then read -m(chief), 5% of that segment's rms for Kr.  A fixed nominal reference length (engine OPDRefRayLen branch, one api wrapper) localises every column</a:t>
             </a:r>
           </a:p>
         </p:txBody>
@@ -3996,7 +3996,7 @@
                 </a:solidFill>
                 <a:latin typeface="Arial"/>
               </a:rPr>
-              <a:t>Gate: tOpdRef/test_driver_single_segment_poke_is_local_under_chief (fails on the previous code).  Default stays 'mean' until the fixed-length reference lands: no committed baseline moves.</a:t>
+              <a:t>Gates: tOpdRef/test_driver_single_segment_poke_is_local_under_chief (e5hex1, driver path; fails on the previous code) and tRunSensitivities/test_dwdsurf_channel_honours_elts_orient_and_opd_ref.  The default stays 'mean' until the fixed-length reference lands: no committed baseline moves.</a:t>
             </a:r>
           </a:p>
         </p:txBody>
@@ -4120,7 +4120,7 @@
       </p:sp>
       <p:pic>
         <p:nvPicPr>
-          <p:cNvPr id="4" name="Picture 3" descr="dwdsurf_opts.png"/>
+          <p:cNvPr id="4" name="Picture 3" descr="dwdsurf_jwst_opts.png"/>
           <p:cNvPicPr>
             <a:picLocks noChangeAspect="1"/>
           </p:cNvPicPr>
@@ -4134,8 +4134,8 @@
         </p:blipFill>
         <p:spPr>
           <a:xfrm>
-            <a:off x="2525484" y="1298448"/>
-            <a:ext cx="7140726" cy="4177792"/>
+            <a:off x="2608113" y="1298448"/>
+            <a:ext cx="6975468" cy="4177792"/>
           </a:xfrm>
           <a:prstGeom prst="rect">
             <a:avLst/>
@@ -4176,7 +4176,7 @@
                 </a:solidFill>
                 <a:latin typeface="Arial"/>
               </a:rPr>
-              <a:t>The same Kr column with PTT removal (top row: mean and chief become identical, and a tilt now runs across all seven segments), raw orientation (bottom left: the same rays, transposed) and the wavefront sign (bottom right: negated).</a:t>
+              <a:t>The same Kr column with PTT removal (top row: mean and chief become identical, and a tilt now runs across all 18 segments), raw orientation (bottom left: the same rays with index 1 along global X, the spiders rotate) and the wavefront sign (bottom right: negated).</a:t>
             </a:r>
           </a:p>
         </p:txBody>
@@ -4215,7 +4215,7 @@
                 </a:solidFill>
                 <a:latin typeface="Arial"/>
               </a:rPr>
-              <a:t>remove_ptt fits global piston/tip/tilt to the whole column: the poked segment biases the fit, so the six unpoked segments trade a flat offset for a tilt and the reference choice no longer matters; orient raw = the engine array (index 1 along global X), xy = imagesc-ready; sign wavefront negates every wavefront output.</a:t>
+              <a:t>surf_remove_ptt fits global piston/tip/tilt to the whole column: the poked segment biases the fit, so the 17 unpoked segments trade a 4.4e-4 flat offset for a tilt of 7.0e-4 rms, and the reference choice no longer matters.  Orientation check: Seg2 sits at (X, Y) = (-1137, +657) mm and its footprint appears at (+10, -6.5) px from the pupil centre in the xy map, i.e. columns run along xGrid = -X and rows along yGrid = -Y (the deck's source frame; magnitudes match the exit-pupil scale).  'xy' fixes the transpose, not the sign of each axis.</a:t>
             </a:r>
           </a:p>
         </p:txBody>
@@ -4347,7 +4347,7 @@
         </p:nvGraphicFramePr>
         <p:xfrm>
           <a:off x="411480" y="1298448"/>
-          <a:ext cx="11368734" cy="1400175"/>
+          <a:ext cx="11368735" cy="2057400"/>
         </p:xfrm>
         <a:graphic>
           <a:graphicData uri="http://schemas.openxmlformats.org/drawingml/2006/table">
@@ -4358,8 +4358,8 @@
               <a:tblGrid>
                 <a:gridCol w="2180336"/>
                 <a:gridCol w="1889760"/>
-                <a:gridCol w="3892607"/>
-                <a:gridCol w="3406031"/>
+                <a:gridCol w="4293317"/>
+                <a:gridCol w="3005322"/>
               </a:tblGrid>
               <a:tr h="280035">
                 <a:tc>
@@ -4721,7 +4721,7 @@
                   </a:tcPr>
                 </a:tc>
               </a:tr>
-              <a:tr h="280035">
+              <a:tr h="468630">
                 <a:tc>
                   <a:txBody>
                     <a:bodyPr wrap="square"/>
@@ -4734,7 +4734,7 @@
                           </a:solidFill>
                           <a:latin typeface="Arial"/>
                         </a:rPr>
-                        <a:t>surf_remove_ptt / remove_ptt</a:t>
+                        <a:t>elts</a:t>
                       </a:r>
                     </a:p>
                   </a:txBody>
@@ -4756,7 +4756,7 @@
                           </a:solidFill>
                           <a:latin typeface="Arial"/>
                         </a:rPr>
-                        <a:t>false (default), true</a:t>
+                        <a:t>[] (all eligible), ids</a:t>
                       </a:r>
                     </a:p>
                   </a:txBody>
@@ -4778,7 +4778,7 @@
                           </a:solidFill>
                           <a:latin typeface="Arial"/>
                         </a:rPr>
-                        <a:t>dwdsurf driver + runner</a:t>
+                        <a:t>run_sensitivities -&gt; all four channels (dwdsurf was dropped)</a:t>
                       </a:r>
                     </a:p>
                   </a:txBody>
@@ -4800,7 +4800,7 @@
                           </a:solidFill>
                           <a:latin typeface="Arial"/>
                         </a:rPr>
-                        <a:t>false (not a substitute for the reference)</a:t>
+                        <a:t>the segments of interest</a:t>
                       </a:r>
                     </a:p>
                   </a:txBody>
@@ -4811,6 +4811,96 @@
                   </a:tcPr>
                 </a:tc>
               </a:tr>
+              <a:tr h="468630">
+                <a:tc>
+                  <a:txBody>
+                    <a:bodyPr wrap="square"/>
+                    <a:lstStyle/>
+                    <a:p>
+                      <a:r>
+                        <a:rPr sz="1100" b="0">
+                          <a:solidFill>
+                            <a:srgbClr val="282828"/>
+                          </a:solidFill>
+                          <a:latin typeface="Arial"/>
+                        </a:rPr>
+                        <a:t>surf_remove_ptt / remove_ptt</a:t>
+                      </a:r>
+                    </a:p>
+                  </a:txBody>
+                  <a:tcPr marL="54864" marR="54864" marT="18288" marB="18288">
+                    <a:solidFill>
+                      <a:srgbClr val="FFFFFF"/>
+                    </a:solidFill>
+                  </a:tcPr>
+                </a:tc>
+                <a:tc>
+                  <a:txBody>
+                    <a:bodyPr wrap="square"/>
+                    <a:lstStyle/>
+                    <a:p>
+                      <a:r>
+                        <a:rPr sz="1100" b="0">
+                          <a:solidFill>
+                            <a:srgbClr val="282828"/>
+                          </a:solidFill>
+                          <a:latin typeface="Arial"/>
+                        </a:rPr>
+                        <a:t>false (default), true</a:t>
+                      </a:r>
+                    </a:p>
+                  </a:txBody>
+                  <a:tcPr marL="54864" marR="54864" marT="18288" marB="18288">
+                    <a:solidFill>
+                      <a:srgbClr val="FFFFFF"/>
+                    </a:solidFill>
+                  </a:tcPr>
+                </a:tc>
+                <a:tc>
+                  <a:txBody>
+                    <a:bodyPr wrap="square"/>
+                    <a:lstStyle/>
+                    <a:p>
+                      <a:r>
+                        <a:rPr sz="1100" b="0">
+                          <a:solidFill>
+                            <a:srgbClr val="282828"/>
+                          </a:solidFill>
+                          <a:latin typeface="Arial"/>
+                        </a:rPr>
+                        <a:t>dwdsurf driver + runner</a:t>
+                      </a:r>
+                    </a:p>
+                  </a:txBody>
+                  <a:tcPr marL="54864" marR="54864" marT="18288" marB="18288">
+                    <a:solidFill>
+                      <a:srgbClr val="FFFFFF"/>
+                    </a:solidFill>
+                  </a:tcPr>
+                </a:tc>
+                <a:tc>
+                  <a:txBody>
+                    <a:bodyPr wrap="square"/>
+                    <a:lstStyle/>
+                    <a:p>
+                      <a:r>
+                        <a:rPr sz="1100" b="0">
+                          <a:solidFill>
+                            <a:srgbClr val="282828"/>
+                          </a:solidFill>
+                          <a:latin typeface="Arial"/>
+                        </a:rPr>
+                        <a:t>false (not a substitute for the reference)</a:t>
+                      </a:r>
+                    </a:p>
+                  </a:txBody>
+                  <a:tcPr marL="54864" marR="54864" marT="18288" marB="18288">
+                    <a:solidFill>
+                      <a:srgbClr val="FFFFFF"/>
+                    </a:solidFill>
+                  </a:tcPr>
+                </a:tc>
+              </a:tr>
             </a:tbl>
           </a:graphicData>
         </a:graphic>
@@ -4823,7 +4913,7 @@
         </p:nvSpPr>
         <p:spPr>
           <a:xfrm>
-            <a:off x="411480" y="2844927"/>
+            <a:off x="411480" y="3502152"/>
             <a:ext cx="11368735" cy="274320"/>
           </a:xfrm>
           <a:prstGeom prst="rect">
@@ -4849,7 +4939,7 @@
                 </a:solidFill>
                 <a:latin typeface="Arial"/>
               </a:rPr>
-              <a:t>run_sensitivities(RX, ..., 'channels', "dwdsurf", 'orient', 'xy', 'opd_ref', 'chief').  Re-applied after every Rx reload (a load resets the reference).  Open for Dave: the fixed nominal reference and the default flip (PLAN 0.x).</a:t>
+              <a:t>run_sensitivities(RX, ..., 'channels', "dwdsurf", 'elts', 5, 'orient', 'xy', 'opd_ref', 'chief').  The reference is re-applied after every Rx reload (a load resets it).  Open for Dave: the fixed nominal reference and the default flip (PLAN 0.x).</a:t>
             </a:r>
           </a:p>
         </p:txBody>

</xml_diff>

<commit_message>
dwdsurf option deck: MATLAB jet, no colour limits (Dave: match Luis's plots); zeros inside the pupil kept as data
Co-Authored-By: Claude Fable 5.1 <noreply@anthropic.com>
</commit_message>
<xml_diff>
--- a/demo_session/deck_dwdsurf_options.pptx
+++ b/demo_session/deck_dwdsurf_options.pptx
@@ -3361,7 +3361,7 @@
                 </a:solidFill>
                 <a:latin typeface="Arial"/>
               </a:rPr>
-              <a:t>Kr and Kc columns of Seg2 under opd_ref = mean (left) and chief (right): the 17 unpoked segments carry a flat offset on the left and exactly nothing on the right; the colour scale is +-3x that offset, so the poked segment saturates.</a:t>
+              <a:t>Kr and Kc columns of Seg2 under opd_ref = mean (left) and chief (right): the 17 unpoked segments carry a flat offset on the left (the colour scale's top) and exactly zero on the right.</a:t>
             </a:r>
           </a:p>
         </p:txBody>
@@ -3400,7 +3400,7 @@
                 </a:solidFill>
                 <a:latin typeface="Arial"/>
               </a:rPr>
-              <a:t>Offset on the unpoked segments under mean = -(N_k/N) x mean(poked response): Kr 4.40e-4, Kc 1.66e-2 per unit parameter (5.4% / 4.5% of the poked segment's rms), equal on all 17 to 6e-16; the mean and chief columns differ by that one constant everywhere (1.4e-12 relative).  orient xy, sign opl, surf_remove_ptt off.</a:t>
+              <a:t>Offset on the unpoked segments under mean = -(N_k/N) x mean(poked response): Kr 4.40e-4, Kc 1.66e-2 per unit parameter (5.4% / 4.5% of the poked segment's rms), equal on all 17 to 6e-16; the mean and chief columns differ by that one constant everywhere (1.4e-12 relative).  orient xy, sign opl, surf_remove_ptt off; MATLAB jet colormap, autoscaled colour limits, as in Luis's plots.</a:t>
             </a:r>
           </a:p>
         </p:txBody>
@@ -4134,8 +4134,8 @@
         </p:blipFill>
         <p:spPr>
           <a:xfrm>
-            <a:off x="2608113" y="1298448"/>
-            <a:ext cx="6975468" cy="4177792"/>
+            <a:off x="2639190" y="1298448"/>
+            <a:ext cx="6913314" cy="4177792"/>
           </a:xfrm>
           <a:prstGeom prst="rect">
             <a:avLst/>

</xml_diff>

<commit_message>
dwdsurf option deck: slides 2-3 from the runner's OWN centre-field pages (mean paints the unpoked segments, chief shows only the poked one) + the orient-xy page scramble before/after; reply item 3; PLAN/slice
Dave 2026-09-10: "show me the plots with opd_ref=chief, without
modification" -- the runner's per-element page was scrambled under
orient xy (plot_dw_per_element index bug, resources 1e0a956), which is
what Luis's pictures showed.  The deck now carries the unmodified pages.

Co-Authored-By: Claude Fable 5.1 <noreply@anthropic.com>
</commit_message>
<xml_diff>
--- a/demo_session/deck_dwdsurf_options.pptx
+++ b/demo_session/deck_dwdsurf_options.pptx
@@ -10,6 +10,7 @@
     <p:sldId id="258" r:id="rId9"/>
     <p:sldId id="259" r:id="rId10"/>
     <p:sldId id="260" r:id="rId11"/>
+    <p:sldId id="261" r:id="rId12"/>
   </p:sldIdLst>
   <p:sldSz cx="12191695" cy="6858000" type="screen4x3"/>
   <p:notesSz cx="6858000" cy="9144000"/>
@@ -3254,7 +3255,7 @@
                 </a:solidFill>
                 <a:latin typeface="Arial"/>
               </a:rPr>
-              <a:t>mean reference: one constant on the other 17; chief reference: exactly zero</a:t>
+              <a:t>the runner's own centre-field page, unmodified: mean paints the other 17 segments, chief shows only the poked one</a:t>
             </a:r>
           </a:p>
         </p:txBody>
@@ -3305,7 +3306,7 @@
       </p:sp>
       <p:pic>
         <p:nvPicPr>
-          <p:cNvPr id="4" name="Picture 3" descr="dwdsurf_jwst_ref.png"/>
+          <p:cNvPr id="4" name="Picture 3" descr="dwdsurf_jwst_page_mean_xy.png"/>
           <p:cNvPicPr>
             <a:picLocks noChangeAspect="1"/>
           </p:cNvPicPr>
@@ -3319,8 +3320,8 @@
         </p:blipFill>
         <p:spPr>
           <a:xfrm>
-            <a:off x="2720448" y="1298448"/>
-            <a:ext cx="6750798" cy="4177792"/>
+            <a:off x="1449590" y="1298448"/>
+            <a:ext cx="3730218" cy="2531872"/>
           </a:xfrm>
           <a:prstGeom prst="rect">
             <a:avLst/>
@@ -3335,8 +3336,8 @@
         </p:nvSpPr>
         <p:spPr>
           <a:xfrm>
-            <a:off x="411480" y="5494528"/>
-            <a:ext cx="11368735" cy="394208"/>
+            <a:off x="411480" y="3848608"/>
+            <a:ext cx="5806440" cy="394208"/>
           </a:xfrm>
           <a:prstGeom prst="rect">
             <a:avLst/>
@@ -3361,20 +3362,83 @@
                 </a:solidFill>
                 <a:latin typeface="Arial"/>
               </a:rPr>
-              <a:t>Kr and Kc columns of Seg2 under opd_ref = mean (left) and chief (right): the 17 unpoked segments carry a flat offset on the left (the colour scale's top) and exactly zero on the right.</a:t>
-            </a:r>
-          </a:p>
-        </p:txBody>
-      </p:sp>
-      <p:sp>
-        <p:nvSpPr>
-          <p:cNvPr id="6" name="TextBox 5"/>
+              <a:t>opd_ref = mean: the 17 unpoked segments appear as one flat colour (the piston-removed constant), the poked Seg2 as the hexagon.</a:t>
+            </a:r>
+          </a:p>
+        </p:txBody>
+      </p:sp>
+      <p:pic>
+        <p:nvPicPr>
+          <p:cNvPr id="6" name="Picture 5" descr="dwdsurf_jwst_page_chief_xy.png"/>
+          <p:cNvPicPr>
+            <a:picLocks noChangeAspect="1"/>
+          </p:cNvPicPr>
+          <p:nvPr/>
+        </p:nvPicPr>
+        <p:blipFill>
+          <a:blip r:embed="rId3"/>
+          <a:stretch>
+            <a:fillRect/>
+          </a:stretch>
+        </p:blipFill>
+        <p:spPr>
+          <a:xfrm>
+            <a:off x="7233170" y="1298448"/>
+            <a:ext cx="3730218" cy="2531872"/>
+          </a:xfrm>
+          <a:prstGeom prst="rect">
+            <a:avLst/>
+          </a:prstGeom>
+        </p:spPr>
+      </p:pic>
+      <p:sp>
+        <p:nvSpPr>
+          <p:cNvPr id="7" name="TextBox 6"/>
           <p:cNvSpPr txBox="1"/>
           <p:nvPr/>
         </p:nvSpPr>
         <p:spPr>
           <a:xfrm>
-            <a:off x="411480" y="5925312"/>
+            <a:off x="6400800" y="3848608"/>
+            <a:ext cx="5394960" cy="394208"/>
+          </a:xfrm>
+          <a:prstGeom prst="rect">
+            <a:avLst/>
+          </a:prstGeom>
+          <a:noFill/>
+        </p:spPr>
+        <p:txBody>
+          <a:bodyPr wrap="square">
+            <a:spAutoFit/>
+          </a:bodyPr>
+          <a:lstStyle/>
+          <a:p>
+            <a:pPr algn="ctr">
+              <a:spcAft>
+                <a:spcPts val="0"/>
+              </a:spcAft>
+            </a:pPr>
+            <a:r>
+              <a:rPr sz="1000" b="0">
+                <a:solidFill>
+                  <a:srgbClr val="6E6E6E"/>
+                </a:solidFill>
+                <a:latin typeface="Arial"/>
+              </a:rPr>
+              <a:t>opd_ref = chief: the unpoked segments read exactly zero and are not drawn; only Seg2 remains.</a:t>
+            </a:r>
+          </a:p>
+        </p:txBody>
+      </p:sp>
+      <p:sp>
+        <p:nvSpPr>
+          <p:cNvPr id="8" name="TextBox 7"/>
+          <p:cNvSpPr txBox="1"/>
+          <p:nvPr/>
+        </p:nvSpPr>
+        <p:spPr>
+          <a:xfrm>
+            <a:off x="411480" y="4279392"/>
             <a:ext cx="11368735" cy="274320"/>
           </a:xfrm>
           <a:prstGeom prst="rect">
@@ -3400,7 +3464,7 @@
                 </a:solidFill>
                 <a:latin typeface="Arial"/>
               </a:rPr>
-              <a:t>Offset on the unpoked segments under mean = -(N_k/N) x mean(poked response): Kr 4.40e-4, Kc 1.66e-2 per unit parameter (5.4% / 4.5% of the poked segment's rms), equal on all 17 to 6e-16; the mean and chief columns differ by that one constant everywhere (1.4e-12 relative).  orient xy, sign opl, surf_remove_ptt off; MATLAB jet colormap, autoscaled colour limits, as in Luis's plots.</a:t>
+              <a:t>run_sensitivities pages (&lt;name&gt;_pages/*_elt5_center.png), orient xy, sign opl, surf_remove_ptt off, piston removed by the page plotter, MATLAB default colormap, autoscaled.  Under mean the offset on the unpoked segments is -(N_k/N) x mean(poked response): Kr 4.40e-4, Kc 1.66e-2 per unit parameter (5.4% / 4.5% of the poked segment's rms), equal on all 17 to 6e-16.</a:t>
             </a:r>
           </a:p>
         </p:txBody>
@@ -3414,6 +3478,288 @@
 </file>
 
 <file path=ppt/slides/slide3.xml><?xml version="1.0" encoding="utf-8"?>
+<p:sld xmlns:a="http://schemas.openxmlformats.org/drawingml/2006/main" xmlns:p="http://schemas.openxmlformats.org/presentationml/2006/main" xmlns:r="http://schemas.openxmlformats.org/officeDocument/2006/relationships">
+  <p:cSld>
+    <p:spTree>
+      <p:nvGrpSpPr>
+        <p:cNvPr id="1" name=""/>
+        <p:cNvGrpSpPr/>
+        <p:nvPr/>
+      </p:nvGrpSpPr>
+      <p:grpSpPr/>
+      <p:sp>
+        <p:nvSpPr>
+          <p:cNvPr id="2" name="TextBox 1"/>
+          <p:cNvSpPr txBox="1"/>
+          <p:nvPr/>
+        </p:nvSpPr>
+        <p:spPr>
+          <a:xfrm>
+            <a:off x="411480" y="201168"/>
+            <a:ext cx="11368735" cy="914400"/>
+          </a:xfrm>
+          <a:prstGeom prst="rect">
+            <a:avLst/>
+          </a:prstGeom>
+          <a:noFill/>
+        </p:spPr>
+        <p:txBody>
+          <a:bodyPr wrap="square">
+            <a:spAutoFit/>
+          </a:bodyPr>
+          <a:lstStyle/>
+          <a:p>
+            <a:pPr>
+              <a:spcAft>
+                <a:spcPts val="400"/>
+              </a:spcAft>
+            </a:pPr>
+            <a:r>
+              <a:rPr sz="2400" b="1">
+                <a:solidFill>
+                  <a:srgbClr val="1F4E79"/>
+                </a:solidFill>
+                <a:latin typeface="Arial"/>
+              </a:rPr>
+              <a:t>Under orient xy the page itself was scrambled</a:t>
+            </a:r>
+          </a:p>
+          <a:p>
+            <a:pPr>
+              <a:spcAft>
+                <a:spcPts val="0"/>
+              </a:spcAft>
+            </a:pPr>
+            <a:r>
+              <a:rPr sz="1250" b="0">
+                <a:solidFill>
+                  <a:srgbClr val="6E6E6E"/>
+                </a:solidFill>
+                <a:latin typeface="Arial"/>
+              </a:rPr>
+              <a:t>the same chief-reference page before and after the plotter fix; the raw-orientation page was always clean</a:t>
+            </a:r>
+          </a:p>
+        </p:txBody>
+      </p:sp>
+      <p:sp>
+        <p:nvSpPr>
+          <p:cNvPr id="3" name="Rectangle 2"/>
+          <p:cNvSpPr/>
+          <p:nvPr/>
+        </p:nvSpPr>
+        <p:spPr>
+          <a:xfrm>
+            <a:off x="411480" y="1133856"/>
+            <a:ext cx="11368735" cy="20320"/>
+          </a:xfrm>
+          <a:prstGeom prst="rect">
+            <a:avLst/>
+          </a:prstGeom>
+          <a:solidFill>
+            <a:srgbClr val="B8C6D4"/>
+          </a:solidFill>
+          <a:ln>
+            <a:noFill/>
+          </a:ln>
+          <a:effectLst/>
+        </p:spPr>
+        <p:style>
+          <a:lnRef idx="1">
+            <a:schemeClr val="accent1"/>
+          </a:lnRef>
+          <a:fillRef idx="3">
+            <a:schemeClr val="accent1"/>
+          </a:fillRef>
+          <a:effectRef idx="2">
+            <a:schemeClr val="accent1"/>
+          </a:effectRef>
+          <a:fontRef idx="minor">
+            <a:schemeClr val="lt1"/>
+          </a:fontRef>
+        </p:style>
+        <p:txBody>
+          <a:bodyPr rtlCol="0" anchor="ctr"/>
+          <a:lstStyle/>
+          <a:p>
+            <a:pPr algn="ctr"/>
+          </a:p>
+        </p:txBody>
+      </p:sp>
+      <p:pic>
+        <p:nvPicPr>
+          <p:cNvPr id="4" name="Picture 3" descr="dwdsurf_jwst_page_chief_xy_OLD.png"/>
+          <p:cNvPicPr>
+            <a:picLocks noChangeAspect="1"/>
+          </p:cNvPicPr>
+          <p:nvPr/>
+        </p:nvPicPr>
+        <p:blipFill>
+          <a:blip r:embed="rId2"/>
+          <a:stretch>
+            <a:fillRect/>
+          </a:stretch>
+        </p:blipFill>
+        <p:spPr>
+          <a:xfrm>
+            <a:off x="1449590" y="1298448"/>
+            <a:ext cx="3730218" cy="2531872"/>
+          </a:xfrm>
+          <a:prstGeom prst="rect">
+            <a:avLst/>
+          </a:prstGeom>
+        </p:spPr>
+      </p:pic>
+      <p:sp>
+        <p:nvSpPr>
+          <p:cNvPr id="5" name="TextBox 4"/>
+          <p:cNvSpPr txBox="1"/>
+          <p:nvPr/>
+        </p:nvSpPr>
+        <p:spPr>
+          <a:xfrm>
+            <a:off x="411480" y="3848608"/>
+            <a:ext cx="5806440" cy="394208"/>
+          </a:xfrm>
+          <a:prstGeom prst="rect">
+            <a:avLst/>
+          </a:prstGeom>
+          <a:noFill/>
+        </p:spPr>
+        <p:txBody>
+          <a:bodyPr wrap="square">
+            <a:spAutoFit/>
+          </a:bodyPr>
+          <a:lstStyle/>
+          <a:p>
+            <a:pPr algn="ctr">
+              <a:spcAft>
+                <a:spcPts val="0"/>
+              </a:spcAft>
+            </a:pPr>
+            <a:r>
+              <a:rPr sz="1000" b="0">
+                <a:solidFill>
+                  <a:srgbClr val="6E6E6E"/>
+                </a:solidFill>
+                <a:latin typeface="Arial"/>
+              </a:rPr>
+              <a:t>Before: the centre-field page rebuilt its pixel index from the transposed nominal map, so the rows landed on the wrong pixels and the hexagon smeared into streaks.</a:t>
+            </a:r>
+          </a:p>
+        </p:txBody>
+      </p:sp>
+      <p:pic>
+        <p:nvPicPr>
+          <p:cNvPr id="6" name="Picture 5" descr="dwdsurf_jwst_page_chief_xy.png"/>
+          <p:cNvPicPr>
+            <a:picLocks noChangeAspect="1"/>
+          </p:cNvPicPr>
+          <p:nvPr/>
+        </p:nvPicPr>
+        <p:blipFill>
+          <a:blip r:embed="rId3"/>
+          <a:stretch>
+            <a:fillRect/>
+          </a:stretch>
+        </p:blipFill>
+        <p:spPr>
+          <a:xfrm>
+            <a:off x="7233170" y="1298448"/>
+            <a:ext cx="3730218" cy="2531872"/>
+          </a:xfrm>
+          <a:prstGeom prst="rect">
+            <a:avLst/>
+          </a:prstGeom>
+        </p:spPr>
+      </p:pic>
+      <p:sp>
+        <p:nvSpPr>
+          <p:cNvPr id="7" name="TextBox 6"/>
+          <p:cNvSpPr txBox="1"/>
+          <p:nvPr/>
+        </p:nvSpPr>
+        <p:spPr>
+          <a:xfrm>
+            <a:off x="6400800" y="3848608"/>
+            <a:ext cx="5394960" cy="394208"/>
+          </a:xfrm>
+          <a:prstGeom prst="rect">
+            <a:avLst/>
+          </a:prstGeom>
+          <a:noFill/>
+        </p:spPr>
+        <p:txBody>
+          <a:bodyPr wrap="square">
+            <a:spAutoFit/>
+          </a:bodyPr>
+          <a:lstStyle/>
+          <a:p>
+            <a:pPr algn="ctr">
+              <a:spcAft>
+                <a:spcPts val="0"/>
+              </a:spcAft>
+            </a:pPr>
+            <a:r>
+              <a:rPr sz="1000" b="0">
+                <a:solidFill>
+                  <a:srgbClr val="6E6E6E"/>
+                </a:solidFill>
+                <a:latin typeface="Arial"/>
+              </a:rPr>
+              <a:t>After: the index is built on the raw-orientation map and remapped with the same rule as the harvest; the xy page is the raw page transposed, exactly.</a:t>
+            </a:r>
+          </a:p>
+        </p:txBody>
+      </p:sp>
+      <p:sp>
+        <p:nvSpPr>
+          <p:cNvPr id="8" name="TextBox 7"/>
+          <p:cNvSpPr txBox="1"/>
+          <p:nvPr/>
+        </p:nvSpPr>
+        <p:spPr>
+          <a:xfrm>
+            <a:off x="411480" y="4279392"/>
+            <a:ext cx="11368735" cy="274320"/>
+          </a:xfrm>
+          <a:prstGeom prst="rect">
+            <a:avLst/>
+          </a:prstGeom>
+          <a:noFill/>
+        </p:spPr>
+        <p:txBody>
+          <a:bodyPr wrap="square">
+            <a:spAutoFit/>
+          </a:bodyPr>
+          <a:lstStyle/>
+          <a:p>
+            <a:pPr>
+              <a:spcAft>
+                <a:spcPts val="600"/>
+              </a:spcAft>
+            </a:pPr>
+            <a:r>
+              <a:rPr sz="1050" b="0">
+                <a:solidFill>
+                  <a:srgbClr val="6E6E6E"/>
+                </a:solidFill>
+                <a:latin typeface="Arial"/>
+              </a:rPr>
+              <a:t>sensitivities/per_field_indx.m; gate tRunSensitivities/test_per_element_page_index_follows_orient_xy (xy page == raw page transposed to 0; the old recipe differs by more than 10% of the map).  This is the picture Luis was reading as a residual.</a:t>
+            </a:r>
+          </a:p>
+        </p:txBody>
+      </p:sp>
+    </p:spTree>
+  </p:cSld>
+  <p:clrMapOvr>
+    <a:masterClrMapping/>
+  </p:clrMapOvr>
+</p:sld>
+</file>
+
+<file path=ppt/slides/slide4.xml><?xml version="1.0" encoding="utf-8"?>
 <p:sld xmlns:a="http://schemas.openxmlformats.org/drawingml/2006/main" xmlns:p="http://schemas.openxmlformats.org/presentationml/2006/main" xmlns:r="http://schemas.openxmlformats.org/officeDocument/2006/relationships">
   <p:cSld>
     <p:spTree>
@@ -4009,7 +4355,7 @@
 </p:sld>
 </file>
 
-<file path=ppt/slides/slide4.xml><?xml version="1.0" encoding="utf-8"?>
+<file path=ppt/slides/slide5.xml><?xml version="1.0" encoding="utf-8"?>
 <p:sld xmlns:a="http://schemas.openxmlformats.org/drawingml/2006/main" xmlns:p="http://schemas.openxmlformats.org/presentationml/2006/main" xmlns:r="http://schemas.openxmlformats.org/officeDocument/2006/relationships">
   <p:cSld>
     <p:spTree>
@@ -4228,7 +4574,7 @@
 </p:sld>
 </file>
 
-<file path=ppt/slides/slide5.xml><?xml version="1.0" encoding="utf-8"?>
+<file path=ppt/slides/slide6.xml><?xml version="1.0" encoding="utf-8"?>
 <p:sld xmlns:a="http://schemas.openxmlformats.org/drawingml/2006/main" xmlns:p="http://schemas.openxmlformats.org/presentationml/2006/main" xmlns:r="http://schemas.openxmlformats.org/officeDocument/2006/relationships">
   <p:cSld>
     <p:spTree>

</xml_diff>

<commit_message>
dwdsurf option deck: every figure is the runner's own centre-field page, unmodified (Dave's rule: deck plots show what the user sees, no AI intervention); my rendered figures removed
Slides: reference (mean paints the 17 unpoked segments, chief shows only
Seg2) / the orient-xy page scramble before-after / mechanism / PTT removal
(mean == chief, a tilt across all 18) / orientation + sign / what to run.
The three xy option pages regenerated with the fixed plotter from the
saved runs.  The raw panel's "two rotated pupils" was my own render's
mask borrowed from the xy run -- gone with the render.

Co-Authored-By: Claude Fable 5.1 <noreply@anthropic.com>
</commit_message>
<xml_diff>
--- a/demo_session/deck_dwdsurf_options.pptx
+++ b/demo_session/deck_dwdsurf_options.pptx
@@ -11,6 +11,7 @@
     <p:sldId id="259" r:id="rId10"/>
     <p:sldId id="260" r:id="rId11"/>
     <p:sldId id="261" r:id="rId12"/>
+    <p:sldId id="262" r:id="rId13"/>
   </p:sldIdLst>
   <p:sldSz cx="12191695" cy="6858000" type="screen4x3"/>
   <p:notesSz cx="6858000" cy="9144000"/>
@@ -3182,7 +3183,7 @@
                 </a:solidFill>
                 <a:latin typeface="Arial"/>
               </a:rPr>
-              <a:t>DRAFT 2026-09-09.  Every option shown is a run_sensitivities option since this date ('orient', 'sign', 'opd_ref', and 'elts' now reach the dwdsurf channel).  Numbers: dW/dp per unit parameter, mm of OPD per mm (Kr) / per unit (Kc), centre field, single configuration.</a:t>
+              <a:t>DRAFT 2026-09-10.  Every figure is the runner's own centre-field page (&lt;name&gt;_pages/*_elt5_center.png), unmodified: MATLAB default colormap, autoscaled, piston removed by the page plotter, zeros not drawn.  Every option shown is a run_sensitivities option since 2026-09-09 ('orient', 'sign', 'opd_ref', and 'elts' now reach the dwdsurf channel).  Numbers: dW/dp per unit parameter, mm of OPD per mm (Kr) / per unit (Kc), centre field, single configuration.</a:t>
             </a:r>
           </a:p>
         </p:txBody>
@@ -4399,7 +4400,7 @@
                 </a:solidFill>
                 <a:latin typeface="Arial"/>
               </a:rPr>
-              <a:t>The other options do not remove the leak; they relabel it</a:t>
+              <a:t>PTT removal does not remove the leak; it relabels it as a tilt</a:t>
             </a:r>
           </a:p>
           <a:p>
@@ -4415,7 +4416,7 @@
                 </a:solidFill>
                 <a:latin typeface="Arial"/>
               </a:rPr>
-              <a:t>PTT removal fits the whole column, orientation transposes, sign negates</a:t>
+              <a:t>with surf_remove_ptt on, the mean and chief pages become identical and a tilt runs across all 18 segments</a:t>
             </a:r>
           </a:p>
         </p:txBody>
@@ -4466,7 +4467,7 @@
       </p:sp>
       <p:pic>
         <p:nvPicPr>
-          <p:cNvPr id="4" name="Picture 3" descr="dwdsurf_jwst_opts.png"/>
+          <p:cNvPr id="4" name="Picture 3" descr="dwdsurf_jwst_page_mean_ptt.png"/>
           <p:cNvPicPr>
             <a:picLocks noChangeAspect="1"/>
           </p:cNvPicPr>
@@ -4480,8 +4481,8 @@
         </p:blipFill>
         <p:spPr>
           <a:xfrm>
-            <a:off x="2639190" y="1298448"/>
-            <a:ext cx="6913314" cy="4177792"/>
+            <a:off x="1449590" y="1298448"/>
+            <a:ext cx="3730218" cy="2531872"/>
           </a:xfrm>
           <a:prstGeom prst="rect">
             <a:avLst/>
@@ -4496,8 +4497,8 @@
         </p:nvSpPr>
         <p:spPr>
           <a:xfrm>
-            <a:off x="411480" y="5494528"/>
-            <a:ext cx="11368735" cy="394208"/>
+            <a:off x="411480" y="3848608"/>
+            <a:ext cx="5806440" cy="394208"/>
           </a:xfrm>
           <a:prstGeom prst="rect">
             <a:avLst/>
@@ -4522,20 +4523,83 @@
                 </a:solidFill>
                 <a:latin typeface="Arial"/>
               </a:rPr>
-              <a:t>The same Kr column with PTT removal (top row: mean and chief become identical, and a tilt now runs across all 18 segments), raw orientation (bottom left: the same rays with index 1 along global X, the spiders rotate) and the wavefront sign (bottom right: negated).</a:t>
-            </a:r>
-          </a:p>
-        </p:txBody>
-      </p:sp>
-      <p:sp>
-        <p:nvSpPr>
-          <p:cNvPr id="6" name="TextBox 5"/>
+              <a:t>surf_remove_ptt = true, opd_ref = mean: the 17 unpoked segments carry a tilt instead of a flat offset.</a:t>
+            </a:r>
+          </a:p>
+        </p:txBody>
+      </p:sp>
+      <p:pic>
+        <p:nvPicPr>
+          <p:cNvPr id="6" name="Picture 5" descr="dwdsurf_jwst_page_chief_ptt.png"/>
+          <p:cNvPicPr>
+            <a:picLocks noChangeAspect="1"/>
+          </p:cNvPicPr>
+          <p:nvPr/>
+        </p:nvPicPr>
+        <p:blipFill>
+          <a:blip r:embed="rId3"/>
+          <a:stretch>
+            <a:fillRect/>
+          </a:stretch>
+        </p:blipFill>
+        <p:spPr>
+          <a:xfrm>
+            <a:off x="7233170" y="1298448"/>
+            <a:ext cx="3730218" cy="2531872"/>
+          </a:xfrm>
+          <a:prstGeom prst="rect">
+            <a:avLst/>
+          </a:prstGeom>
+        </p:spPr>
+      </p:pic>
+      <p:sp>
+        <p:nvSpPr>
+          <p:cNvPr id="7" name="TextBox 6"/>
           <p:cNvSpPr txBox="1"/>
           <p:nvPr/>
         </p:nvSpPr>
         <p:spPr>
           <a:xfrm>
-            <a:off x="411480" y="5925312"/>
+            <a:off x="6400800" y="3848608"/>
+            <a:ext cx="5394960" cy="394208"/>
+          </a:xfrm>
+          <a:prstGeom prst="rect">
+            <a:avLst/>
+          </a:prstGeom>
+          <a:noFill/>
+        </p:spPr>
+        <p:txBody>
+          <a:bodyPr wrap="square">
+            <a:spAutoFit/>
+          </a:bodyPr>
+          <a:lstStyle/>
+          <a:p>
+            <a:pPr algn="ctr">
+              <a:spcAft>
+                <a:spcPts val="0"/>
+              </a:spcAft>
+            </a:pPr>
+            <a:r>
+              <a:rPr sz="1000" b="0">
+                <a:solidFill>
+                  <a:srgbClr val="6E6E6E"/>
+                </a:solidFill>
+                <a:latin typeface="Arial"/>
+              </a:rPr>
+              <a:t>surf_remove_ptt = true, opd_ref = chief: identical to the mean page, the global piston/tip/tilt fit has absorbed the reference difference.</a:t>
+            </a:r>
+          </a:p>
+        </p:txBody>
+      </p:sp>
+      <p:sp>
+        <p:nvSpPr>
+          <p:cNvPr id="8" name="TextBox 7"/>
+          <p:cNvSpPr txBox="1"/>
+          <p:nvPr/>
+        </p:nvSpPr>
+        <p:spPr>
+          <a:xfrm>
+            <a:off x="411480" y="4279392"/>
             <a:ext cx="11368735" cy="274320"/>
           </a:xfrm>
           <a:prstGeom prst="rect">
@@ -4561,7 +4625,7 @@
                 </a:solidFill>
                 <a:latin typeface="Arial"/>
               </a:rPr>
-              <a:t>surf_remove_ptt fits global piston/tip/tilt to the whole column: the poked segment biases the fit, so the 17 unpoked segments trade a 4.4e-4 flat offset for a tilt of 7.0e-4 rms, and the reference choice no longer matters.  Orientation check: Seg2 sits at (X, Y) = (-1137, +657) mm and its footprint appears at (+10, -6.5) px from the pupil centre in the xy map, i.e. columns run along xGrid = -X and rows along yGrid = -Y (the deck's source frame; magnitudes match the exit-pupil scale).  'xy' fixes the transpose, not the sign of each axis.</a:t>
+              <a:t>Runner pages, unmodified.  The fit is global, so the poked segment biases it: the unpoked segments' rms goes from 4.4e-4 (flat offset under mean) to 7.0e-4 (tilt), the same under either reference.</a:t>
             </a:r>
           </a:p>
         </p:txBody>
@@ -4575,6 +4639,288 @@
 </file>
 
 <file path=ppt/slides/slide6.xml><?xml version="1.0" encoding="utf-8"?>
+<p:sld xmlns:a="http://schemas.openxmlformats.org/drawingml/2006/main" xmlns:p="http://schemas.openxmlformats.org/presentationml/2006/main" xmlns:r="http://schemas.openxmlformats.org/officeDocument/2006/relationships">
+  <p:cSld>
+    <p:spTree>
+      <p:nvGrpSpPr>
+        <p:cNvPr id="1" name=""/>
+        <p:cNvGrpSpPr/>
+        <p:nvPr/>
+      </p:nvGrpSpPr>
+      <p:grpSpPr/>
+      <p:sp>
+        <p:nvSpPr>
+          <p:cNvPr id="2" name="TextBox 1"/>
+          <p:cNvSpPr txBox="1"/>
+          <p:nvPr/>
+        </p:nvSpPr>
+        <p:spPr>
+          <a:xfrm>
+            <a:off x="411480" y="201168"/>
+            <a:ext cx="11368735" cy="914400"/>
+          </a:xfrm>
+          <a:prstGeom prst="rect">
+            <a:avLst/>
+          </a:prstGeom>
+          <a:noFill/>
+        </p:spPr>
+        <p:txBody>
+          <a:bodyPr wrap="square">
+            <a:spAutoFit/>
+          </a:bodyPr>
+          <a:lstStyle/>
+          <a:p>
+            <a:pPr>
+              <a:spcAft>
+                <a:spcPts val="400"/>
+              </a:spcAft>
+            </a:pPr>
+            <a:r>
+              <a:rPr sz="2400" b="1">
+                <a:solidFill>
+                  <a:srgbClr val="1F4E79"/>
+                </a:solidFill>
+                <a:latin typeface="Arial"/>
+              </a:rPr>
+              <a:t>Orientation transposes the array; sign negates it</a:t>
+            </a:r>
+          </a:p>
+          <a:p>
+            <a:pPr>
+              <a:spcAft>
+                <a:spcPts val="0"/>
+              </a:spcAft>
+            </a:pPr>
+            <a:r>
+              <a:rPr sz="1250" b="0">
+                <a:solidFill>
+                  <a:srgbClr val="6E6E6E"/>
+                </a:solidFill>
+                <a:latin typeface="Arial"/>
+              </a:rPr>
+              <a:t>raw is the engine array (index 1 along global X), xy is its transpose; wavefront is opl negated</a:t>
+            </a:r>
+          </a:p>
+        </p:txBody>
+      </p:sp>
+      <p:sp>
+        <p:nvSpPr>
+          <p:cNvPr id="3" name="Rectangle 2"/>
+          <p:cNvSpPr/>
+          <p:nvPr/>
+        </p:nvSpPr>
+        <p:spPr>
+          <a:xfrm>
+            <a:off x="411480" y="1133856"/>
+            <a:ext cx="11368735" cy="20320"/>
+          </a:xfrm>
+          <a:prstGeom prst="rect">
+            <a:avLst/>
+          </a:prstGeom>
+          <a:solidFill>
+            <a:srgbClr val="B8C6D4"/>
+          </a:solidFill>
+          <a:ln>
+            <a:noFill/>
+          </a:ln>
+          <a:effectLst/>
+        </p:spPr>
+        <p:style>
+          <a:lnRef idx="1">
+            <a:schemeClr val="accent1"/>
+          </a:lnRef>
+          <a:fillRef idx="3">
+            <a:schemeClr val="accent1"/>
+          </a:fillRef>
+          <a:effectRef idx="2">
+            <a:schemeClr val="accent1"/>
+          </a:effectRef>
+          <a:fontRef idx="minor">
+            <a:schemeClr val="lt1"/>
+          </a:fontRef>
+        </p:style>
+        <p:txBody>
+          <a:bodyPr rtlCol="0" anchor="ctr"/>
+          <a:lstStyle/>
+          <a:p>
+            <a:pPr algn="ctr"/>
+          </a:p>
+        </p:txBody>
+      </p:sp>
+      <p:pic>
+        <p:nvPicPr>
+          <p:cNvPr id="4" name="Picture 3" descr="dwdsurf_jwst_page_mean_raw.png"/>
+          <p:cNvPicPr>
+            <a:picLocks noChangeAspect="1"/>
+          </p:cNvPicPr>
+          <p:nvPr/>
+        </p:nvPicPr>
+        <p:blipFill>
+          <a:blip r:embed="rId2"/>
+          <a:stretch>
+            <a:fillRect/>
+          </a:stretch>
+        </p:blipFill>
+        <p:spPr>
+          <a:xfrm>
+            <a:off x="1449590" y="1298448"/>
+            <a:ext cx="3730218" cy="2531872"/>
+          </a:xfrm>
+          <a:prstGeom prst="rect">
+            <a:avLst/>
+          </a:prstGeom>
+        </p:spPr>
+      </p:pic>
+      <p:sp>
+        <p:nvSpPr>
+          <p:cNvPr id="5" name="TextBox 4"/>
+          <p:cNvSpPr txBox="1"/>
+          <p:nvPr/>
+        </p:nvSpPr>
+        <p:spPr>
+          <a:xfrm>
+            <a:off x="411480" y="3848608"/>
+            <a:ext cx="5806440" cy="394208"/>
+          </a:xfrm>
+          <a:prstGeom prst="rect">
+            <a:avLst/>
+          </a:prstGeom>
+          <a:noFill/>
+        </p:spPr>
+        <p:txBody>
+          <a:bodyPr wrap="square">
+            <a:spAutoFit/>
+          </a:bodyPr>
+          <a:lstStyle/>
+          <a:p>
+            <a:pPr algn="ctr">
+              <a:spcAft>
+                <a:spcPts val="0"/>
+              </a:spcAft>
+            </a:pPr>
+            <a:r>
+              <a:rPr sz="1000" b="0">
+                <a:solidFill>
+                  <a:srgbClr val="6E6E6E"/>
+                </a:solidFill>
+                <a:latin typeface="Arial"/>
+              </a:rPr>
+              <a:t>orient = raw, opd_ref = mean: the same rays as the xy page, transposed (the spider arms rotate); the unpoked segments carry the same flat offset.</a:t>
+            </a:r>
+          </a:p>
+        </p:txBody>
+      </p:sp>
+      <p:pic>
+        <p:nvPicPr>
+          <p:cNvPr id="6" name="Picture 5" descr="dwdsurf_jwst_page_chief_wf.png"/>
+          <p:cNvPicPr>
+            <a:picLocks noChangeAspect="1"/>
+          </p:cNvPicPr>
+          <p:nvPr/>
+        </p:nvPicPr>
+        <p:blipFill>
+          <a:blip r:embed="rId3"/>
+          <a:stretch>
+            <a:fillRect/>
+          </a:stretch>
+        </p:blipFill>
+        <p:spPr>
+          <a:xfrm>
+            <a:off x="7233170" y="1298448"/>
+            <a:ext cx="3730218" cy="2531872"/>
+          </a:xfrm>
+          <a:prstGeom prst="rect">
+            <a:avLst/>
+          </a:prstGeom>
+        </p:spPr>
+      </p:pic>
+      <p:sp>
+        <p:nvSpPr>
+          <p:cNvPr id="7" name="TextBox 6"/>
+          <p:cNvSpPr txBox="1"/>
+          <p:nvPr/>
+        </p:nvSpPr>
+        <p:spPr>
+          <a:xfrm>
+            <a:off x="6400800" y="3848608"/>
+            <a:ext cx="5394960" cy="394208"/>
+          </a:xfrm>
+          <a:prstGeom prst="rect">
+            <a:avLst/>
+          </a:prstGeom>
+          <a:noFill/>
+        </p:spPr>
+        <p:txBody>
+          <a:bodyPr wrap="square">
+            <a:spAutoFit/>
+          </a:bodyPr>
+          <a:lstStyle/>
+          <a:p>
+            <a:pPr algn="ctr">
+              <a:spcAft>
+                <a:spcPts val="0"/>
+              </a:spcAft>
+            </a:pPr>
+            <a:r>
+              <a:rPr sz="1000" b="0">
+                <a:solidFill>
+                  <a:srgbClr val="6E6E6E"/>
+                </a:solidFill>
+                <a:latin typeface="Arial"/>
+              </a:rPr>
+              <a:t>sign = wavefront, opd_ref = chief, orient xy: the poked segment's response negated, nothing else drawn.</a:t>
+            </a:r>
+          </a:p>
+        </p:txBody>
+      </p:sp>
+      <p:sp>
+        <p:nvSpPr>
+          <p:cNvPr id="8" name="TextBox 7"/>
+          <p:cNvSpPr txBox="1"/>
+          <p:nvPr/>
+        </p:nvSpPr>
+        <p:spPr>
+          <a:xfrm>
+            <a:off x="411480" y="4279392"/>
+            <a:ext cx="11368735" cy="274320"/>
+          </a:xfrm>
+          <a:prstGeom prst="rect">
+            <a:avLst/>
+          </a:prstGeom>
+          <a:noFill/>
+        </p:spPr>
+        <p:txBody>
+          <a:bodyPr wrap="square">
+            <a:spAutoFit/>
+          </a:bodyPr>
+          <a:lstStyle/>
+          <a:p>
+            <a:pPr>
+              <a:spcAft>
+                <a:spcPts val="600"/>
+              </a:spcAft>
+            </a:pPr>
+            <a:r>
+              <a:rPr sz="1050" b="0">
+                <a:solidFill>
+                  <a:srgbClr val="6E6E6E"/>
+                </a:solidFill>
+                <a:latin typeface="Arial"/>
+              </a:rPr>
+              <a:t>Runner pages, unmodified.  Orientation anchor: Seg2 sits at (X, Y) = (-1137, +657) mm; in the xy page its footprint is at (+10, -6.5) px from the pupil centre, i.e. columns run along xGrid = -X and rows along yGrid = -Y (the deck's source frame).  'xy' fixes the transpose, not the sign of each axis.</a:t>
+            </a:r>
+          </a:p>
+        </p:txBody>
+      </p:sp>
+    </p:spTree>
+  </p:cSld>
+  <p:clrMapOvr>
+    <a:masterClrMapping/>
+  </p:clrMapOvr>
+</p:sld>
+</file>
+
+<file path=ppt/slides/slide7.xml><?xml version="1.0" encoding="utf-8"?>
 <p:sld xmlns:a="http://schemas.openxmlformats.org/drawingml/2006/main" xmlns:p="http://schemas.openxmlformats.org/presentationml/2006/main" xmlns:r="http://schemas.openxmlformats.org/officeDocument/2006/relationships">
   <p:cSld>
     <p:spTree>

</xml_diff>

<commit_message>
dwdsurf option deck: runner pages regenerated in jet; 'leak' wording retired (Dave: the mean and remove_ptt results are the same correct data under a different convention); reply + PLAN aligned
Co-Authored-By: Claude Fable 5.1 <noreply@anthropic.com>
</commit_message>
<xml_diff>
--- a/demo_session/deck_dwdsurf_options.pptx
+++ b/demo_session/deck_dwdsurf_options.pptx
@@ -3183,7 +3183,7 @@
                 </a:solidFill>
                 <a:latin typeface="Arial"/>
               </a:rPr>
-              <a:t>DRAFT 2026-09-10.  Every figure is the runner's own centre-field page (&lt;name&gt;_pages/*_elt5_center.png), unmodified: MATLAB default colormap, autoscaled, piston removed by the page plotter, zeros not drawn.  Every option shown is a run_sensitivities option since 2026-09-09 ('orient', 'sign', 'opd_ref', and 'elts' now reach the dwdsurf channel).  Numbers: dW/dp per unit parameter, mm of OPD per mm (Kr) / per unit (Kc), centre field, single configuration.</a:t>
+              <a:t>DRAFT 2026-09-10.  Every figure is the runner's own centre-field page (&lt;name&gt;_pages/*_elt5_center.png), unmodified: colormap jet, autoscaled, piston removed by the page plotter, zeros not drawn.  Every option shown is a run_sensitivities option since 2026-09-09 ('orient', 'sign', 'opd_ref', and 'elts' now reach the dwdsurf channel).  Numbers: dW/dp per unit parameter, mm of OPD per mm (Kr) / per unit (Kc), centre field, single configuration.</a:t>
             </a:r>
           </a:p>
         </p:txBody>
@@ -3256,7 +3256,7 @@
                 </a:solidFill>
                 <a:latin typeface="Arial"/>
               </a:rPr>
-              <a:t>the runner's own centre-field page, unmodified: mean paints the other 17 segments, chief shows only the poked one</a:t>
+              <a:t>the same correct data under two references: mean paints the other 17 segments one flat colour, chief shows only the poked one</a:t>
             </a:r>
           </a:p>
         </p:txBody>
@@ -3465,7 +3465,7 @@
                 </a:solidFill>
                 <a:latin typeface="Arial"/>
               </a:rPr>
-              <a:t>run_sensitivities pages (&lt;name&gt;_pages/*_elt5_center.png), orient xy, sign opl, surf_remove_ptt off, piston removed by the page plotter, MATLAB default colormap, autoscaled.  Under mean the offset on the unpoked segments is -(N_k/N) x mean(poked response): Kr 4.40e-4, Kc 1.66e-2 per unit parameter (5.4% / 4.5% of the poked segment's rms), equal on all 17 to 6e-16.</a:t>
+              <a:t>run_sensitivities pages (&lt;name&gt;_pages/*_elt5_center.png), orient xy, sign opl, surf_remove_ptt off, piston removed by the page plotter, jet, autoscaled.  The two columns differ by one constant everywhere (neither is wrong); under mean the constant the unpoked segments carry is -(N_k/N) x mean(poked response): Kr 4.40e-4, Kc 1.66e-2 per unit parameter (5.4% / 4.5% of the poked segment's rms), equal on all 17 to 6e-16.</a:t>
             </a:r>
           </a:p>
         </p:txBody>
@@ -3820,7 +3820,7 @@
                 </a:solidFill>
                 <a:latin typeface="Arial"/>
               </a:rPr>
-              <a:t>poking one segment moves the aperture-mean reference; the chief ray's does not move unless its own segment is poked</a:t>
+              <a:t>poking one segment moves the aperture-mean reference; the chief ray's does not move unless its own segment is poked -- a convention, not an error</a:t>
             </a:r>
           </a:p>
         </p:txBody>
@@ -4400,7 +4400,7 @@
                 </a:solidFill>
                 <a:latin typeface="Arial"/>
               </a:rPr>
-              <a:t>PTT removal does not remove the leak; it relabels it as a tilt</a:t>
+              <a:t>PTT removal is a third convention on the same data</a:t>
             </a:r>
           </a:p>
           <a:p>
@@ -4416,7 +4416,7 @@
                 </a:solidFill>
                 <a:latin typeface="Arial"/>
               </a:rPr>
-              <a:t>with surf_remove_ptt on, the mean and chief pages become identical and a tilt runs across all 18 segments</a:t>
+              <a:t>with surf_remove_ptt on, the mean and chief pages become identical and the unpoked segments show a tilt instead of a flat offset</a:t>
             </a:r>
           </a:p>
         </p:txBody>
@@ -4523,7 +4523,7 @@
                 </a:solidFill>
                 <a:latin typeface="Arial"/>
               </a:rPr>
-              <a:t>surf_remove_ptt = true, opd_ref = mean: the 17 unpoked segments carry a tilt instead of a flat offset.</a:t>
+              <a:t>surf_remove_ptt = true, opd_ref = mean: the 17 unpoked segments show a tilt instead of a flat offset.</a:t>
             </a:r>
           </a:p>
         </p:txBody>
@@ -4625,7 +4625,7 @@
                 </a:solidFill>
                 <a:latin typeface="Arial"/>
               </a:rPr>
-              <a:t>Runner pages, unmodified.  The fit is global, so the poked segment biases it: the unpoked segments' rms goes from 4.4e-4 (flat offset under mean) to 7.0e-4 (tilt), the same under either reference.</a:t>
+              <a:t>Runner pages, unmodified.  The fit is global, so the poked segment sets it: the unpoked segments' rms is 7.0e-4 (a tilt) against 4.4e-4 (the flat offset under mean), the same under either reference.  Pick the convention the consumer expects; none of the three is an error.</a:t>
             </a:r>
           </a:p>
         </p:txBody>
@@ -5039,7 +5039,7 @@
         </p:nvGraphicFramePr>
         <p:xfrm>
           <a:off x="411480" y="1298448"/>
-          <a:ext cx="11368735" cy="2057400"/>
+          <a:ext cx="11368734" cy="1680210"/>
         </p:xfrm>
         <a:graphic>
           <a:graphicData uri="http://schemas.openxmlformats.org/drawingml/2006/table">
@@ -5050,8 +5050,8 @@
               <a:tblGrid>
                 <a:gridCol w="2180336"/>
                 <a:gridCol w="1889760"/>
-                <a:gridCol w="4293317"/>
-                <a:gridCol w="3005322"/>
+                <a:gridCol w="4379183"/>
+                <a:gridCol w="2919455"/>
               </a:tblGrid>
               <a:tr h="280035">
                 <a:tc>
@@ -5222,7 +5222,7 @@
                           </a:solidFill>
                           <a:latin typeface="Arial"/>
                         </a:rPr>
-                        <a:t>chief</a:t>
+                        <a:t>chief, if unpoked segments should read 0</a:t>
                       </a:r>
                     </a:p>
                   </a:txBody>
@@ -5413,7 +5413,7 @@
                   </a:tcPr>
                 </a:tc>
               </a:tr>
-              <a:tr h="468630">
+              <a:tr h="280035">
                 <a:tc>
                   <a:txBody>
                     <a:bodyPr wrap="square"/>
@@ -5503,7 +5503,7 @@
                   </a:tcPr>
                 </a:tc>
               </a:tr>
-              <a:tr h="468630">
+              <a:tr h="280035">
                 <a:tc>
                   <a:txBody>
                     <a:bodyPr wrap="square"/>
@@ -5582,7 +5582,7 @@
                           </a:solidFill>
                           <a:latin typeface="Arial"/>
                         </a:rPr>
-                        <a:t>false (not a substitute for the reference)</a:t>
+                        <a:t>as the consumer expects</a:t>
                       </a:r>
                     </a:p>
                   </a:txBody>
@@ -5605,7 +5605,7 @@
         </p:nvSpPr>
         <p:spPr>
           <a:xfrm>
-            <a:off x="411480" y="3502152"/>
+            <a:off x="411480" y="3124962"/>
             <a:ext cx="11368735" cy="274320"/>
           </a:xfrm>
           <a:prstGeom prst="rect">

</xml_diff>